<commit_message>
Final: report (docx, fields updated), presentation, polish
Co-Authored-By: Claude Sonnet 5.5 <noreply@anthropic.com>
</commit_message>
<xml_diff>
--- a/presentation/OEE_Smart_Factory_Presentation.pptx
+++ b/presentation/OEE_Smart_Factory_Presentation.pptx
@@ -6263,7 +6263,7 @@
           <a:p>
             <a:pPr algn="ctr"/>
             <a:r>
-              <a:rPr sz="1800" b="1">
+              <a:rPr sz="2200" b="1">
                 <a:solidFill>
                   <a:srgbClr val="111827"/>
                 </a:solidFill>
@@ -6279,7 +6279,7 @@
               </a:spcBef>
             </a:pPr>
             <a:r>
-              <a:rPr sz="1500" b="0">
+              <a:rPr sz="1800" b="0">
                 <a:solidFill>
                   <a:srgbClr val="111827"/>
                 </a:solidFill>
@@ -6288,7 +6288,7 @@
               <a:t>• Trained on </a:t>
             </a:r>
             <a:r>
-              <a:rPr sz="1500" b="1">
+              <a:rPr sz="1800" b="1">
                 <a:solidFill>
                   <a:srgbClr val="111827"/>
                 </a:solidFill>
@@ -6297,7 +6297,7 @@
               <a:t>synthetic normal</a:t>
             </a:r>
             <a:r>
-              <a:rPr sz="1500" b="0">
+              <a:rPr sz="1800" b="0">
                 <a:solidFill>
                   <a:srgbClr val="111827"/>
                 </a:solidFill>
@@ -6313,7 +6313,7 @@
               </a:spcBef>
             </a:pPr>
             <a:r>
-              <a:rPr sz="1500" b="0">
+              <a:rPr sz="1800" b="0">
                 <a:solidFill>
                   <a:srgbClr val="111827"/>
                 </a:solidFill>
@@ -6329,7 +6329,7 @@
               </a:spcBef>
             </a:pPr>
             <a:r>
-              <a:rPr sz="1500" b="0">
+              <a:rPr sz="1800" b="0">
                 <a:solidFill>
                   <a:srgbClr val="111827"/>
                 </a:solidFill>
@@ -6338,7 +6338,7 @@
               <a:t>• Score calibrated to </a:t>
             </a:r>
             <a:r>
-              <a:rPr sz="1500" b="1">
+              <a:rPr sz="1800" b="1">
                 <a:solidFill>
                   <a:srgbClr val="111827"/>
                 </a:solidFill>
@@ -6347,7 +6347,7 @@
               <a:t>0–100 %</a:t>
             </a:r>
             <a:r>
-              <a:rPr sz="1500" b="0">
+              <a:rPr sz="1800" b="0">
                 <a:solidFill>
                   <a:srgbClr val="111827"/>
                 </a:solidFill>
@@ -6363,7 +6363,7 @@
               </a:spcBef>
             </a:pPr>
             <a:r>
-              <a:rPr sz="1500" b="0">
+              <a:rPr sz="1800" b="0">
                 <a:solidFill>
                   <a:srgbClr val="111827"/>
                 </a:solidFill>
@@ -6372,7 +6372,7 @@
               <a:t>• Inference </a:t>
             </a:r>
             <a:r>
-              <a:rPr sz="1500" b="1">
+              <a:rPr sz="1800" b="1">
                 <a:solidFill>
                   <a:srgbClr val="111827"/>
                 </a:solidFill>
@@ -6381,7 +6381,7 @@
               <a:t>≤ 36 ms</a:t>
             </a:r>
             <a:r>
-              <a:rPr sz="1500" b="0">
+              <a:rPr sz="1800" b="0">
                 <a:solidFill>
                   <a:srgbClr val="111827"/>
                 </a:solidFill>
@@ -6397,7 +6397,7 @@
               </a:spcBef>
             </a:pPr>
             <a:r>
-              <a:rPr sz="1500" b="0">
+              <a:rPr sz="1800" b="0">
                 <a:solidFill>
                   <a:srgbClr val="111827"/>
                 </a:solidFill>
@@ -6406,7 +6406,7 @@
               <a:t>• Validation on injected faults: </a:t>
             </a:r>
             <a:r>
-              <a:rPr sz="1500" b="1">
+              <a:rPr sz="1800" b="1">
                 <a:solidFill>
                   <a:srgbClr val="111827"/>
                 </a:solidFill>
@@ -6422,7 +6422,7 @@
               </a:spcBef>
             </a:pPr>
             <a:r>
-              <a:rPr sz="1500" b="0">
+              <a:rPr sz="1800" b="0">
                 <a:solidFill>
                   <a:srgbClr val="111827"/>
                 </a:solidFill>
@@ -6479,7 +6479,7 @@
           <a:p>
             <a:pPr algn="ctr"/>
             <a:r>
-              <a:rPr sz="1800" b="1">
+              <a:rPr sz="2200" b="1">
                 <a:solidFill>
                   <a:srgbClr val="111827"/>
                 </a:solidFill>
@@ -6495,7 +6495,7 @@
               </a:spcBef>
             </a:pPr>
             <a:r>
-              <a:rPr sz="1500" b="0">
+              <a:rPr sz="1800" b="0">
                 <a:solidFill>
                   <a:srgbClr val="111827"/>
                 </a:solidFill>
@@ -6504,7 +6504,7 @@
               <a:t>• Least-squares line through the last </a:t>
             </a:r>
             <a:r>
-              <a:rPr sz="1500" b="1">
+              <a:rPr sz="1800" b="1">
                 <a:solidFill>
                   <a:srgbClr val="111827"/>
                 </a:solidFill>
@@ -6513,7 +6513,7 @@
               <a:t>3 min</a:t>
             </a:r>
             <a:r>
-              <a:rPr sz="1500" b="0">
+              <a:rPr sz="1800" b="0">
                 <a:solidFill>
                   <a:srgbClr val="111827"/>
                 </a:solidFill>
@@ -6529,7 +6529,7 @@
               </a:spcBef>
             </a:pPr>
             <a:r>
-              <a:rPr sz="1500" b="0">
+              <a:rPr sz="1800" b="0">
                 <a:solidFill>
                   <a:srgbClr val="111827"/>
                 </a:solidFill>
@@ -6545,7 +6545,7 @@
               </a:spcBef>
             </a:pPr>
             <a:r>
-              <a:rPr sz="1500" b="0">
+              <a:rPr sz="1800" b="0">
                 <a:solidFill>
                   <a:srgbClr val="111827"/>
                 </a:solidFill>
@@ -6554,7 +6554,7 @@
               <a:t>• </a:t>
             </a:r>
             <a:r>
-              <a:rPr sz="1500" b="1">
+              <a:rPr sz="1800" b="1">
                 <a:solidFill>
                   <a:srgbClr val="111827"/>
                 </a:solidFill>
@@ -6563,7 +6563,7 @@
               <a:t>Orange</a:t>
             </a:r>
             <a:r>
-              <a:rPr sz="1500" b="0">
+              <a:rPr sz="1800" b="0">
                 <a:solidFill>
                   <a:srgbClr val="111827"/>
                 </a:solidFill>
@@ -6572,7 +6572,7 @@
               <a:t> when ETA ≤ </a:t>
             </a:r>
             <a:r>
-              <a:rPr sz="1500" b="1">
+              <a:rPr sz="1800" b="1">
                 <a:solidFill>
                   <a:srgbClr val="111827"/>
                 </a:solidFill>
@@ -6581,7 +6581,7 @@
               <a:t>60 s</a:t>
             </a:r>
             <a:r>
-              <a:rPr sz="1500" b="0">
+              <a:rPr sz="1800" b="0">
                 <a:solidFill>
                   <a:srgbClr val="111827"/>
                 </a:solidFill>
@@ -6597,7 +6597,7 @@
               </a:spcBef>
             </a:pPr>
             <a:r>
-              <a:rPr sz="1500" b="0">
+              <a:rPr sz="1800" b="0">
                 <a:solidFill>
                   <a:srgbClr val="111827"/>
                 </a:solidFill>
@@ -6613,7 +6613,7 @@
               </a:spcBef>
             </a:pPr>
             <a:r>
-              <a:rPr sz="1500" b="0">
+              <a:rPr sz="1800" b="0">
                 <a:solidFill>
                   <a:srgbClr val="111827"/>
                 </a:solidFill>
@@ -6629,7 +6629,7 @@
               </a:spcBef>
             </a:pPr>
             <a:r>
-              <a:rPr sz="1500" b="0">
+              <a:rPr sz="1800" b="0">
                 <a:solidFill>
                   <a:srgbClr val="111827"/>
                 </a:solidFill>
@@ -8722,7 +8722,7 @@
           <a:p>
             <a:pPr algn="ctr"/>
             <a:r>
-              <a:rPr sz="1800" b="1">
+              <a:rPr sz="2200" b="1">
                 <a:solidFill>
                   <a:srgbClr val="111827"/>
                 </a:solidFill>
@@ -8738,7 +8738,7 @@
               </a:spcBef>
             </a:pPr>
             <a:r>
-              <a:rPr sz="1500" b="0">
+              <a:rPr sz="1900" b="0">
                 <a:solidFill>
                   <a:srgbClr val="111827"/>
                 </a:solidFill>
@@ -8754,7 +8754,7 @@
               </a:spcBef>
             </a:pPr>
             <a:r>
-              <a:rPr sz="1500" b="0">
+              <a:rPr sz="1900" b="0">
                 <a:solidFill>
                   <a:srgbClr val="111827"/>
                 </a:solidFill>
@@ -8770,7 +8770,7 @@
               </a:spcBef>
             </a:pPr>
             <a:r>
-              <a:rPr sz="1500" b="0">
+              <a:rPr sz="1900" b="0">
                 <a:solidFill>
                   <a:srgbClr val="111827"/>
                 </a:solidFill>
@@ -8786,7 +8786,7 @@
               </a:spcBef>
             </a:pPr>
             <a:r>
-              <a:rPr sz="1500" b="0">
+              <a:rPr sz="1900" b="0">
                 <a:solidFill>
                   <a:srgbClr val="111827"/>
                 </a:solidFill>
@@ -8802,7 +8802,7 @@
               </a:spcBef>
             </a:pPr>
             <a:r>
-              <a:rPr sz="1500" b="0">
+              <a:rPr sz="1900" b="0">
                 <a:solidFill>
                   <a:srgbClr val="111827"/>
                 </a:solidFill>
@@ -8859,7 +8859,7 @@
           <a:p>
             <a:pPr algn="ctr"/>
             <a:r>
-              <a:rPr sz="1800" b="1">
+              <a:rPr sz="2200" b="1">
                 <a:solidFill>
                   <a:srgbClr val="111827"/>
                 </a:solidFill>
@@ -8875,7 +8875,7 @@
               </a:spcBef>
             </a:pPr>
             <a:r>
-              <a:rPr sz="1500" b="0">
+              <a:rPr sz="1900" b="0">
                 <a:solidFill>
                   <a:srgbClr val="111827"/>
                 </a:solidFill>
@@ -8891,7 +8891,7 @@
               </a:spcBef>
             </a:pPr>
             <a:r>
-              <a:rPr sz="1500" b="0">
+              <a:rPr sz="1900" b="0">
                 <a:solidFill>
                   <a:srgbClr val="111827"/>
                 </a:solidFill>
@@ -8907,7 +8907,7 @@
               </a:spcBef>
             </a:pPr>
             <a:r>
-              <a:rPr sz="1500" b="0">
+              <a:rPr sz="1900" b="0">
                 <a:solidFill>
                   <a:srgbClr val="111827"/>
                 </a:solidFill>
@@ -8923,7 +8923,7 @@
               </a:spcBef>
             </a:pPr>
             <a:r>
-              <a:rPr sz="1500" b="0">
+              <a:rPr sz="1900" b="0">
                 <a:solidFill>
                   <a:srgbClr val="111827"/>
                 </a:solidFill>
@@ -8939,7 +8939,7 @@
               </a:spcBef>
             </a:pPr>
             <a:r>
-              <a:rPr sz="1500" b="0">
+              <a:rPr sz="1900" b="0">
                 <a:solidFill>
                   <a:srgbClr val="111827"/>
                 </a:solidFill>
@@ -8996,7 +8996,7 @@
           <a:p>
             <a:pPr algn="ctr"/>
             <a:r>
-              <a:rPr sz="1800" b="1">
+              <a:rPr sz="2200" b="1">
                 <a:solidFill>
                   <a:srgbClr val="111827"/>
                 </a:solidFill>
@@ -9012,7 +9012,7 @@
               </a:spcBef>
             </a:pPr>
             <a:r>
-              <a:rPr sz="1500" b="0">
+              <a:rPr sz="1900" b="0">
                 <a:solidFill>
                   <a:srgbClr val="111827"/>
                 </a:solidFill>
@@ -9028,7 +9028,7 @@
               </a:spcBef>
             </a:pPr>
             <a:r>
-              <a:rPr sz="1500" b="0">
+              <a:rPr sz="1900" b="0">
                 <a:solidFill>
                   <a:srgbClr val="111827"/>
                 </a:solidFill>
@@ -9044,7 +9044,7 @@
               </a:spcBef>
             </a:pPr>
             <a:r>
-              <a:rPr sz="1500" b="0">
+              <a:rPr sz="1900" b="0">
                 <a:solidFill>
                   <a:srgbClr val="111827"/>
                 </a:solidFill>
@@ -9060,7 +9060,7 @@
               </a:spcBef>
             </a:pPr>
             <a:r>
-              <a:rPr sz="1500" b="0">
+              <a:rPr sz="1900" b="0">
                 <a:solidFill>
                   <a:srgbClr val="111827"/>
                 </a:solidFill>

</xml_diff>